<commit_message>
fix(pptx): clean template asset, skip footer on cover slides
Template cleanup (zero runtime code changes):
- Pre-cleaned default-pptx-master.pptx: removed think-cell OLE objects,
  co-authoring history (changesInfos/revisionInfo), think-cell tags,
  orphan themes (theme2/3), EMF placeholders
- Fixed notesMaster/handoutMaster rels to point to theme1 instead of
  removed theme2/3
- Result: 21 clean files, zero dangling references

Cover footer fix:
- addFooter() now accepts slideType param, skips covers
- Fallback cover renders branding + date as direct text, no footer row
- COVER_TRANSLATION_EXAMPLE updated with branding + date addText calls
- System prompt updated: "skip addFooter for covers"

Co-Authored-By: Claude Opus 4.6 (1M context) <noreply@anthropic.com>
</commit_message>
<xml_diff>
--- a/backend/assets/default-pptx-master.pptx
+++ b/backend/assets/default-pptx-master.pptx
@@ -15,9 +15,6 @@
   </p:sldIdLst>
   <p:sldSz cx="12192000" cy="6858000"/>
   <p:notesSz cx="6858000" cy="9144000"/>
-  <p:custDataLst>
-    <p:tags r:id="rId5"/>
-  </p:custDataLst>
   <p:defaultTextStyle>
     <a:defPPr>
       <a:defRPr lang="en-US"/>
@@ -114,52 +111,6 @@
     </a:lvl9pPr>
   </p:defaultTextStyle>
 </p:presentation>
-</file>
-
-<file path=ppt/revisionInfo.xml><?xml version="1.0" encoding="utf-8"?>
-<p1510:revInfo xmlns:a="http://schemas.openxmlformats.org/drawingml/2006/main" xmlns:r="http://schemas.openxmlformats.org/officeDocument/2006/relationships" xmlns:p1510="http://schemas.microsoft.com/office/powerpoint/2015/10/main">
-  <p1510:revLst>
-    <p1510:client id="{AE169B9A-A09C-4DEA-A22B-FC8AD0ED9A4E}" v="2" dt="2026-03-24T16:17:49.330"/>
-  </p1510:revLst>
-</p1510:revInfo>
-</file>
-
-<file path=ppt/changesInfos/changesInfo1.xml><?xml version="1.0" encoding="utf-8"?>
-<pc:chgInfo xmlns:a="http://schemas.openxmlformats.org/drawingml/2006/main" xmlns:r="http://schemas.openxmlformats.org/officeDocument/2006/relationships" xmlns:ac="http://schemas.microsoft.com/office/drawing/2013/main/command" xmlns:pc="http://schemas.microsoft.com/office/powerpoint/2013/main/command">
-  <pc:docChgLst>
-    <pc:chgData name="Bahaa Kaaki (MiddleEast)" userId="b98e7d85-bbd1-42ea-bc6d-8befd3653b6e" providerId="ADAL" clId="{DB9160D9-9485-4B39-8B2F-22A37C7D1F03}"/>
-    <pc:docChg chg="undo custSel modMainMaster">
-      <pc:chgData name="Bahaa Kaaki (MiddleEast)" userId="b98e7d85-bbd1-42ea-bc6d-8befd3653b6e" providerId="ADAL" clId="{DB9160D9-9485-4B39-8B2F-22A37C7D1F03}" dt="2026-03-24T16:17:49.330" v="1" actId="1076"/>
-      <pc:docMkLst>
-        <pc:docMk/>
-      </pc:docMkLst>
-      <pc:sldMasterChg chg="modSldLayout">
-        <pc:chgData name="Bahaa Kaaki (MiddleEast)" userId="b98e7d85-bbd1-42ea-bc6d-8befd3653b6e" providerId="ADAL" clId="{DB9160D9-9485-4B39-8B2F-22A37C7D1F03}" dt="2026-03-24T16:17:49.330" v="1" actId="1076"/>
-        <pc:sldMasterMkLst>
-          <pc:docMk/>
-          <pc:sldMasterMk cId="4244215101" sldId="2147483726"/>
-        </pc:sldMasterMkLst>
-        <pc:sldLayoutChg chg="modSp mod">
-          <pc:chgData name="Bahaa Kaaki (MiddleEast)" userId="b98e7d85-bbd1-42ea-bc6d-8befd3653b6e" providerId="ADAL" clId="{DB9160D9-9485-4B39-8B2F-22A37C7D1F03}" dt="2026-03-24T16:17:49.330" v="1" actId="1076"/>
-          <pc:sldLayoutMkLst>
-            <pc:docMk/>
-            <pc:sldMasterMk cId="4244215101" sldId="2147483726"/>
-            <pc:sldLayoutMk cId="1925264751" sldId="2147483778"/>
-          </pc:sldLayoutMkLst>
-          <pc:spChg chg="mod">
-            <ac:chgData name="Bahaa Kaaki (MiddleEast)" userId="b98e7d85-bbd1-42ea-bc6d-8befd3653b6e" providerId="ADAL" clId="{DB9160D9-9485-4B39-8B2F-22A37C7D1F03}" dt="2026-03-24T16:17:49.330" v="1" actId="1076"/>
-            <ac:spMkLst>
-              <pc:docMk/>
-              <pc:sldMasterMk cId="4244215101" sldId="2147483726"/>
-              <pc:sldLayoutMk cId="1925264751" sldId="2147483778"/>
-              <ac:spMk id="2" creationId="{336FC979-760C-CD9C-5C10-561F4665F667}"/>
-            </ac:spMkLst>
-          </pc:spChg>
-        </pc:sldLayoutChg>
-      </pc:sldMasterChg>
-    </pc:docChg>
-  </pc:docChgLst>
-</pc:chgInfo>
 </file>
 
 <file path=ppt/handoutMasters/handoutMaster1.xml><?xml version="1.0" encoding="utf-8"?>
@@ -717,78 +668,6 @@
           <a:chExt cx="0" cy="0"/>
         </a:xfrm>
       </p:grpSpPr>
-      <p:graphicFrame>
-        <p:nvGraphicFramePr>
-          <p:cNvPr id="8" name="Object 7" hidden="1">
-            <a:extLst>
-              <a:ext uri="{FF2B5EF4-FFF2-40B4-BE49-F238E27FC236}">
-                <a16:creationId xmlns:a16="http://schemas.microsoft.com/office/drawing/2014/main" id="{1E74CF8E-7A35-42FD-94D9-646327B4F2FF}"/>
-              </a:ext>
-            </a:extLst>
-          </p:cNvPr>
-          <p:cNvGraphicFramePr>
-            <a:graphicFrameLocks noChangeAspect="1"/>
-          </p:cNvGraphicFramePr>
-          <p:nvPr userDrawn="1">
-            <p:custDataLst>
-              <p:tags r:id="rId1"/>
-            </p:custDataLst>
-            <p:extLst>
-              <p:ext uri="{D42A27DB-BD31-4B8C-83A1-F6EECF244321}">
-                <p14:modId xmlns:p14="http://schemas.microsoft.com/office/powerpoint/2010/main" val="421810460"/>
-              </p:ext>
-            </p:extLst>
-          </p:nvPr>
-        </p:nvGraphicFramePr>
-        <p:xfrm>
-          <a:off x="1588" y="1588"/>
-          <a:ext cx="1588" cy="1588"/>
-        </p:xfrm>
-        <a:graphic>
-          <a:graphicData uri="http://schemas.openxmlformats.org/presentationml/2006/ole">
-            <mc:AlternateContent xmlns:mc="http://schemas.openxmlformats.org/markup-compatibility/2006">
-              <mc:Choice xmlns:v="urn:schemas-microsoft-com:vml" Requires="v">
-                <p:oleObj name="think-cell Slide" r:id="rId3" imgW="473" imgH="473" progId="TCLayout.ActiveDocument.1">
-                  <p:embed/>
-                </p:oleObj>
-              </mc:Choice>
-              <mc:Fallback>
-                <p:oleObj name="think-cell Slide" r:id="rId3" imgW="473" imgH="473" progId="TCLayout.ActiveDocument.1">
-                  <p:embed/>
-                  <p:pic>
-                    <p:nvPicPr>
-                      <p:cNvPr id="8" name="Object 7" hidden="1">
-                        <a:extLst>
-                          <a:ext uri="{FF2B5EF4-FFF2-40B4-BE49-F238E27FC236}">
-                            <a16:creationId xmlns:a16="http://schemas.microsoft.com/office/drawing/2014/main" id="{1E74CF8E-7A35-42FD-94D9-646327B4F2FF}"/>
-                          </a:ext>
-                        </a:extLst>
-                      </p:cNvPr>
-                      <p:cNvPicPr/>
-                      <p:nvPr/>
-                    </p:nvPicPr>
-                    <p:blipFill>
-                      <a:blip r:embed="rId4"/>
-                      <a:stretch>
-                        <a:fillRect/>
-                      </a:stretch>
-                    </p:blipFill>
-                    <p:spPr>
-                      <a:xfrm>
-                        <a:off x="1588" y="1588"/>
-                        <a:ext cx="1588" cy="1588"/>
-                      </a:xfrm>
-                      <a:prstGeom prst="rect">
-                        <a:avLst/>
-                      </a:prstGeom>
-                    </p:spPr>
-                  </p:pic>
-                </p:oleObj>
-              </mc:Fallback>
-            </mc:AlternateContent>
-          </a:graphicData>
-        </a:graphic>
-      </p:graphicFrame>
       <p:sp>
         <p:nvSpPr>
           <p:cNvPr id="7" name="Title">
@@ -1211,66 +1090,6 @@
           <a:chExt cx="0" cy="0"/>
         </a:xfrm>
       </p:grpSpPr>
-      <p:graphicFrame>
-        <p:nvGraphicFramePr>
-          <p:cNvPr id="8" name="Object 7" hidden="1"/>
-          <p:cNvGraphicFramePr>
-            <a:graphicFrameLocks noChangeAspect="1"/>
-          </p:cNvGraphicFramePr>
-          <p:nvPr userDrawn="1">
-            <p:custDataLst>
-              <p:tags r:id="rId3"/>
-            </p:custDataLst>
-            <p:extLst>
-              <p:ext uri="{D42A27DB-BD31-4B8C-83A1-F6EECF244321}">
-                <p14:modId xmlns:p14="http://schemas.microsoft.com/office/powerpoint/2010/main" val="3586046917"/>
-              </p:ext>
-            </p:extLst>
-          </p:nvPr>
-        </p:nvGraphicFramePr>
-        <p:xfrm>
-          <a:off x="1927" y="1408"/>
-          <a:ext cx="1924" cy="1401"/>
-        </p:xfrm>
-        <a:graphic>
-          <a:graphicData uri="http://schemas.openxmlformats.org/presentationml/2006/ole">
-            <mc:AlternateContent xmlns:mc="http://schemas.openxmlformats.org/markup-compatibility/2006">
-              <mc:Choice xmlns:v="urn:schemas-microsoft-com:vml" Requires="v">
-                <p:oleObj name="think-cell Slide" r:id="rId5" imgW="415" imgH="416" progId="TCLayout.ActiveDocument.1">
-                  <p:embed/>
-                </p:oleObj>
-              </mc:Choice>
-              <mc:Fallback>
-                <p:oleObj name="think-cell Slide" r:id="rId5" imgW="415" imgH="416" progId="TCLayout.ActiveDocument.1">
-                  <p:embed/>
-                  <p:pic>
-                    <p:nvPicPr>
-                      <p:cNvPr id="8" name="Object 7" hidden="1"/>
-                      <p:cNvPicPr/>
-                      <p:nvPr/>
-                    </p:nvPicPr>
-                    <p:blipFill>
-                      <a:blip r:embed="rId6"/>
-                      <a:stretch>
-                        <a:fillRect/>
-                      </a:stretch>
-                    </p:blipFill>
-                    <p:spPr>
-                      <a:xfrm>
-                        <a:off x="1927" y="1408"/>
-                        <a:ext cx="1924" cy="1401"/>
-                      </a:xfrm>
-                      <a:prstGeom prst="rect">
-                        <a:avLst/>
-                      </a:prstGeom>
-                    </p:spPr>
-                  </p:pic>
-                </p:oleObj>
-              </mc:Fallback>
-            </mc:AlternateContent>
-          </a:graphicData>
-        </a:graphic>
-      </p:graphicFrame>
       <p:sp>
         <p:nvSpPr>
           <p:cNvPr id="7" name="Rectangle 6" hidden="1"/>
@@ -2215,32 +2034,6 @@
 </p:sld>
 </file>
 
-<file path=ppt/tags/tag1.xml><?xml version="1.0" encoding="utf-8"?>
-<p:tagLst xmlns:a="http://schemas.openxmlformats.org/drawingml/2006/main" xmlns:r="http://schemas.openxmlformats.org/officeDocument/2006/relationships" xmlns:p="http://schemas.openxmlformats.org/presentationml/2006/main">
-  <p:tag name="THINKCELLPRESENTATIONDONOTDELETE" val="&lt;?xml version=&quot;1.0&quot; encoding=&quot;UTF-16&quot; standalone=&quot;yes&quot;?&gt;&lt;root reqver=&quot;27037&quot;&gt;&lt;version val=&quot;32852&quot;/&gt;&lt;CPresentation id=&quot;1&quot;&gt;&lt;m_precDefaultNumber&gt;&lt;m_bNumberIsYear val=&quot;1&quot;/&gt;&lt;m_chMinusSymbol&gt;-&lt;/m_chMinusSymbol&gt;&lt;m_chDecimalSymbol17909&gt;.&lt;/m_chDecimalSymbol17909&gt;&lt;m_nGroupingDigits17909 val=&quot;3&quot;/&gt;&lt;m_chGroupingSymbol17909&gt;,&lt;/m_chGroupingSymbol17909&gt;&lt;m_yearfmt&gt;&lt;begin val=&quot;0&quot;/&gt;&lt;end val=&quot;4&quot;/&gt;&lt;/m_yearfmt&gt;&lt;/m_precDefaultNumber&gt;&lt;m_precDefaultPercent&gt;&lt;m_bNumberIsYear val=&quot;1&quot;/&gt;&lt;m_chMinusSymbol&gt;-&lt;/m_chMinusSymbol&gt;&lt;m_nDecimalDigits17909 val=&quot;0&quot;/&gt;&lt;m_chDecimalSymbol17909&gt;.&lt;/m_chDecimalSymbol17909&gt;&lt;m_nGroupingDigits17909 val=&quot;3&quot;/&gt;&lt;m_chGroupingSymbol17909&gt;,&lt;/m_chGroupingSymbol17909&gt;&lt;m_strSuffix17909&gt;%&lt;/m_strSuffix17909&gt;&lt;m_yearfmt&gt;&lt;begin val=&quot;0&quot;/&gt;&lt;end val=&quot;4&quot;/&gt;&lt;/m_yearfmt&gt;&lt;/m_precDefaultPercent&gt;&lt;m_precDefaultDate&gt;&lt;m_bNumberIsYear val=&quot;0&quot;/&gt;&lt;m_strFormatTime&gt;%#m/%#d&lt;/m_strFormatTime&gt;&lt;m_yearfmt&gt;&lt;begin val=&quot;0&quot;/&gt;&lt;end val=&quot;0&quot;/&gt;&lt;/m_yearfmt&gt;&lt;/m_precDefaultDate&gt;&lt;m_precDefaultDay&gt;&lt;m_bNumberIsYear val=&quot;0&quot;/&gt;&lt;m_strFormatTime&gt;%#d&lt;/m_strFormatTime&gt;&lt;m_yearfmt&gt;&lt;begin val=&quot;0&quot;/&gt;&lt;end val=&quot;4&quot;/&gt;&lt;/m_yearfmt&gt;&lt;/m_precDefaultDay&gt;&lt;m_precDefaultWeek&gt;&lt;m_yearfmt&gt;&lt;begin val=&quot;0&quot;/&gt;&lt;end val=&quot;4&quot;/&gt;&lt;/m_yearfmt&gt;&lt;/m_precDefaultWeek&gt;&lt;m_precDefaultMonth&gt;&lt;m_bNumberIsYear val=&quot;0&quot;/&gt;&lt;m_strFormatTime&gt;%1&lt;/m_strFormatTime&gt;&lt;m_yearfmt&gt;&lt;begin val=&quot;0&quot;/&gt;&lt;end val=&quot;4&quot;/&gt;&lt;/m_yearfmt&gt;&lt;/m_precDefaultMonth&gt;&lt;m_precDefaultQuarter&gt;&lt;m_bNumberIsYear val=&quot;0&quot;/&gt;&lt;m_strFormatTime&gt;Q%5&lt;/m_strFormatTime&gt;&lt;m_yearfmt&gt;&lt;begin val=&quot;0&quot;/&gt;&lt;end val=&quot;4&quot;/&gt;&lt;/m_yearfmt&gt;&lt;/m_precDefaultQuarter&gt;&lt;m_precDefaultYear&gt;&lt;m_bNumberIsYear val=&quot;0&quot;/&gt;&lt;m_strFormatTime&gt;%Y&lt;/m_strFormatTime&gt;&lt;m_yearfmt&gt;&lt;begin val=&quot;0&quot;/&gt;&lt;end val=&quot;0&quot;/&gt;&lt;/m_yearfmt&gt;&lt;/m_precDefaultYear&gt;&lt;m_precDefaultFYDay&gt;&lt;m_yearfmt&gt;&lt;begin val=&quot;0&quot;/&gt;&lt;end val=&quot;4&quot;/&gt;&lt;/m_yearfmt&gt;&lt;/m_precDefaultFYDay&gt;&lt;m_precDefaultFYWeek&gt;&lt;m_yearfmt&gt;&lt;begin val=&quot;0&quot;/&gt;&lt;end val=&quot;4&quot;/&gt;&lt;/m_yearfmt&gt;&lt;/m_precDefaultFYWeek&gt;&lt;m_precDefaultFYMonth&gt;&lt;m_yearfmt&gt;&lt;begin val=&quot;0&quot;/&gt;&lt;end val=&quot;4&quot;/&gt;&lt;/m_yearfmt&gt;&lt;/m_precDefaultFYMonth&gt;&lt;m_precDefaultFYQuarter&gt;&lt;m_yearfmt&gt;&lt;begin val=&quot;0&quot;/&gt;&lt;end val=&quot;4&quot;/&gt;&lt;/m_yearfmt&gt;&lt;/m_precDefaultFYQuarter&gt;&lt;m_precDefaultFYYear&gt;&lt;m_yearfmt&gt;&lt;begin val=&quot;0&quot;/&gt;&lt;end val=&quot;4&quot;/&gt;&lt;/m_yearfmt&gt;&lt;/m_precDefaultFYYear&gt;&lt;m_mruColor&gt;&lt;m_vecMRU length=&quot;2&quot;&gt;&lt;elem m_fUsage=&quot;2.70999999999999996447E+00&quot;&gt;&lt;m_msothmcolidx val=&quot;0&quot;/&gt;&lt;m_rgb r=&quot;F9&quot; g=&quot;62&quot; b=&quot;12&quot;/&gt;&lt;/elem&gt;&lt;elem m_fUsage=&quot;7.29000000000000092371E-01&quot;&gt;&lt;m_msothmcolidx val=&quot;0&quot;/&gt;&lt;m_rgb r=&quot;DA&quot; g=&quot;DA&quot; b=&quot;DA&quot;/&gt;&lt;/elem&gt;&lt;/m_vecMRU&gt;&lt;/m_mruColor&gt;&lt;m_eweekdayFirstOfWeek val=&quot;2&quot;/&gt;&lt;m_eweekdayFirstOfWorkweek val=&quot;1&quot;/&gt;&lt;m_eweekdayFirstOfWeekend val=&quot;6&quot;/&gt;&lt;/CPresentation&gt;&lt;/root&gt;"/>
-  <p:tag name="THINKCELLUNDODONOTDELETE" val="0"/>
-  <p:tag name="LASTSLIDEVIEWED" val="2147479891,24,Our approach consists of four main pillars"/>
-</p:tagLst>
-</file>
-
-<file path=ppt/tags/tag2.xml><?xml version="1.0" encoding="utf-8"?>
-<p:tagLst xmlns:a="http://schemas.openxmlformats.org/drawingml/2006/main" xmlns:r="http://schemas.openxmlformats.org/officeDocument/2006/relationships" xmlns:p="http://schemas.openxmlformats.org/presentationml/2006/main">
-  <p:tag name="THINKCELLSHAPEDONOTDELETE" val="thinkcellActiveDocDoNotDelete"/>
-</p:tagLst>
-</file>
-
-<file path=ppt/tags/tag3.xml><?xml version="1.0" encoding="utf-8"?>
-<p:tagLst xmlns:a="http://schemas.openxmlformats.org/drawingml/2006/main" xmlns:r="http://schemas.openxmlformats.org/officeDocument/2006/relationships" xmlns:p="http://schemas.openxmlformats.org/presentationml/2006/main">
-  <p:tag name="THINKCELLSHAPEDONOTDELETE" val="tPuUx_gg7jMOGCXTSUL3Ogw"/>
-</p:tagLst>
-</file>
-
-<file path=ppt/tags/tag4.xml><?xml version="1.0" encoding="utf-8"?>
-<p:tagLst xmlns:a="http://schemas.openxmlformats.org/drawingml/2006/main" xmlns:r="http://schemas.openxmlformats.org/officeDocument/2006/relationships" xmlns:p="http://schemas.openxmlformats.org/presentationml/2006/main">
-  <p:tag name="THINKCELLSHAPEDONOTDELETE" val="thinkcellActiveDocDoNotDelete"/>
-</p:tagLst>
-</file>
-
 <file path=ppt/theme/theme1.xml><?xml version="1.0" encoding="utf-8"?>
 <a:theme xmlns:a="http://schemas.openxmlformats.org/drawingml/2006/main" name="Widescreen 16x9 Template">
   <a:themeElements>
@@ -2539,594 +2332,4 @@
     </a:ext>
   </a:extLst>
 </a:theme>
-</file>
-
-<file path=ppt/theme/theme2.xml><?xml version="1.0" encoding="utf-8"?>
-<a:theme xmlns:a="http://schemas.openxmlformats.org/drawingml/2006/main" name="Office Theme">
-  <a:themeElements>
-    <a:clrScheme name="Office">
-      <a:dk1>
-        <a:sysClr val="windowText" lastClr="000000"/>
-      </a:dk1>
-      <a:lt1>
-        <a:sysClr val="window" lastClr="FFFFFF"/>
-      </a:lt1>
-      <a:dk2>
-        <a:srgbClr val="44546A"/>
-      </a:dk2>
-      <a:lt2>
-        <a:srgbClr val="E7E6E6"/>
-      </a:lt2>
-      <a:accent1>
-        <a:srgbClr val="4472C4"/>
-      </a:accent1>
-      <a:accent2>
-        <a:srgbClr val="ED7D31"/>
-      </a:accent2>
-      <a:accent3>
-        <a:srgbClr val="A5A5A5"/>
-      </a:accent3>
-      <a:accent4>
-        <a:srgbClr val="FFC000"/>
-      </a:accent4>
-      <a:accent5>
-        <a:srgbClr val="5B9BD5"/>
-      </a:accent5>
-      <a:accent6>
-        <a:srgbClr val="70AD47"/>
-      </a:accent6>
-      <a:hlink>
-        <a:srgbClr val="0563C1"/>
-      </a:hlink>
-      <a:folHlink>
-        <a:srgbClr val="954F72"/>
-      </a:folHlink>
-    </a:clrScheme>
-    <a:fontScheme name="Office">
-      <a:majorFont>
-        <a:latin typeface="Calibri Light" panose="020F0302020204030204"/>
-        <a:ea typeface=""/>
-        <a:cs typeface=""/>
-        <a:font script="Jpan" typeface="游ゴシック Light"/>
-        <a:font script="Hang" typeface="맑은 고딕"/>
-        <a:font script="Hans" typeface="等线 Light"/>
-        <a:font script="Hant" typeface="新細明體"/>
-        <a:font script="Arab" typeface="Times New Roman"/>
-        <a:font script="Hebr" typeface="Times New Roman"/>
-        <a:font script="Thai" typeface="Angsana New"/>
-        <a:font script="Ethi" typeface="Nyala"/>
-        <a:font script="Beng" typeface="Vrinda"/>
-        <a:font script="Gujr" typeface="Shruti"/>
-        <a:font script="Khmr" typeface="MoolBoran"/>
-        <a:font script="Knda" typeface="Tunga"/>
-        <a:font script="Guru" typeface="Raavi"/>
-        <a:font script="Cans" typeface="Euphemia"/>
-        <a:font script="Cher" typeface="Plantagenet Cherokee"/>
-        <a:font script="Yiii" typeface="Microsoft Yi Baiti"/>
-        <a:font script="Tibt" typeface="Microsoft Himalaya"/>
-        <a:font script="Thaa" typeface="MV Boli"/>
-        <a:font script="Deva" typeface="Mangal"/>
-        <a:font script="Telu" typeface="Gautami"/>
-        <a:font script="Taml" typeface="Latha"/>
-        <a:font script="Syrc" typeface="Estrangelo Edessa"/>
-        <a:font script="Orya" typeface="Kalinga"/>
-        <a:font script="Mlym" typeface="Kartika"/>
-        <a:font script="Laoo" typeface="DokChampa"/>
-        <a:font script="Sinh" typeface="Iskoola Pota"/>
-        <a:font script="Mong" typeface="Mongolian Baiti"/>
-        <a:font script="Viet" typeface="Times New Roman"/>
-        <a:font script="Uigh" typeface="Microsoft Uighur"/>
-        <a:font script="Geor" typeface="Sylfaen"/>
-        <a:font script="Armn" typeface="Arial"/>
-        <a:font script="Bugi" typeface="Leelawadee UI"/>
-        <a:font script="Bopo" typeface="Microsoft JhengHei"/>
-        <a:font script="Java" typeface="Javanese Text"/>
-        <a:font script="Lisu" typeface="Segoe UI"/>
-        <a:font script="Mymr" typeface="Myanmar Text"/>
-        <a:font script="Nkoo" typeface="Ebrima"/>
-        <a:font script="Olck" typeface="Nirmala UI"/>
-        <a:font script="Osma" typeface="Ebrima"/>
-        <a:font script="Phag" typeface="Phagspa"/>
-        <a:font script="Syrn" typeface="Estrangelo Edessa"/>
-        <a:font script="Syrj" typeface="Estrangelo Edessa"/>
-        <a:font script="Syre" typeface="Estrangelo Edessa"/>
-        <a:font script="Sora" typeface="Nirmala UI"/>
-        <a:font script="Tale" typeface="Microsoft Tai Le"/>
-        <a:font script="Talu" typeface="Microsoft New Tai Lue"/>
-        <a:font script="Tfng" typeface="Ebrima"/>
-      </a:majorFont>
-      <a:minorFont>
-        <a:latin typeface="Calibri" panose="020F0502020204030204"/>
-        <a:ea typeface=""/>
-        <a:cs typeface=""/>
-        <a:font script="Jpan" typeface="游ゴシック"/>
-        <a:font script="Hang" typeface="맑은 고딕"/>
-        <a:font script="Hans" typeface="等线"/>
-        <a:font script="Hant" typeface="新細明體"/>
-        <a:font script="Arab" typeface="Arial"/>
-        <a:font script="Hebr" typeface="Arial"/>
-        <a:font script="Thai" typeface="Cordia New"/>
-        <a:font script="Ethi" typeface="Nyala"/>
-        <a:font script="Beng" typeface="Vrinda"/>
-        <a:font script="Gujr" typeface="Shruti"/>
-        <a:font script="Khmr" typeface="DaunPenh"/>
-        <a:font script="Knda" typeface="Tunga"/>
-        <a:font script="Guru" typeface="Raavi"/>
-        <a:font script="Cans" typeface="Euphemia"/>
-        <a:font script="Cher" typeface="Plantagenet Cherokee"/>
-        <a:font script="Yiii" typeface="Microsoft Yi Baiti"/>
-        <a:font script="Tibt" typeface="Microsoft Himalaya"/>
-        <a:font script="Thaa" typeface="MV Boli"/>
-        <a:font script="Deva" typeface="Mangal"/>
-        <a:font script="Telu" typeface="Gautami"/>
-        <a:font script="Taml" typeface="Latha"/>
-        <a:font script="Syrc" typeface="Estrangelo Edessa"/>
-        <a:font script="Orya" typeface="Kalinga"/>
-        <a:font script="Mlym" typeface="Kartika"/>
-        <a:font script="Laoo" typeface="DokChampa"/>
-        <a:font script="Sinh" typeface="Iskoola Pota"/>
-        <a:font script="Mong" typeface="Mongolian Baiti"/>
-        <a:font script="Viet" typeface="Arial"/>
-        <a:font script="Uigh" typeface="Microsoft Uighur"/>
-        <a:font script="Geor" typeface="Sylfaen"/>
-        <a:font script="Armn" typeface="Arial"/>
-        <a:font script="Bugi" typeface="Leelawadee UI"/>
-        <a:font script="Bopo" typeface="Microsoft JhengHei"/>
-        <a:font script="Java" typeface="Javanese Text"/>
-        <a:font script="Lisu" typeface="Segoe UI"/>
-        <a:font script="Mymr" typeface="Myanmar Text"/>
-        <a:font script="Nkoo" typeface="Ebrima"/>
-        <a:font script="Olck" typeface="Nirmala UI"/>
-        <a:font script="Osma" typeface="Ebrima"/>
-        <a:font script="Phag" typeface="Phagspa"/>
-        <a:font script="Syrn" typeface="Estrangelo Edessa"/>
-        <a:font script="Syrj" typeface="Estrangelo Edessa"/>
-        <a:font script="Syre" typeface="Estrangelo Edessa"/>
-        <a:font script="Sora" typeface="Nirmala UI"/>
-        <a:font script="Tale" typeface="Microsoft Tai Le"/>
-        <a:font script="Talu" typeface="Microsoft New Tai Lue"/>
-        <a:font script="Tfng" typeface="Ebrima"/>
-      </a:minorFont>
-    </a:fontScheme>
-    <a:fmtScheme name="Office">
-      <a:fillStyleLst>
-        <a:solidFill>
-          <a:schemeClr val="phClr"/>
-        </a:solidFill>
-        <a:gradFill rotWithShape="1">
-          <a:gsLst>
-            <a:gs pos="0">
-              <a:schemeClr val="phClr">
-                <a:lumMod val="110000"/>
-                <a:satMod val="105000"/>
-                <a:tint val="67000"/>
-              </a:schemeClr>
-            </a:gs>
-            <a:gs pos="50000">
-              <a:schemeClr val="phClr">
-                <a:lumMod val="105000"/>
-                <a:satMod val="103000"/>
-                <a:tint val="73000"/>
-              </a:schemeClr>
-            </a:gs>
-            <a:gs pos="100000">
-              <a:schemeClr val="phClr">
-                <a:lumMod val="105000"/>
-                <a:satMod val="109000"/>
-                <a:tint val="81000"/>
-              </a:schemeClr>
-            </a:gs>
-          </a:gsLst>
-          <a:lin ang="5400000" scaled="0"/>
-        </a:gradFill>
-        <a:gradFill rotWithShape="1">
-          <a:gsLst>
-            <a:gs pos="0">
-              <a:schemeClr val="phClr">
-                <a:satMod val="103000"/>
-                <a:lumMod val="102000"/>
-                <a:tint val="94000"/>
-              </a:schemeClr>
-            </a:gs>
-            <a:gs pos="50000">
-              <a:schemeClr val="phClr">
-                <a:satMod val="110000"/>
-                <a:lumMod val="100000"/>
-                <a:shade val="100000"/>
-              </a:schemeClr>
-            </a:gs>
-            <a:gs pos="100000">
-              <a:schemeClr val="phClr">
-                <a:lumMod val="99000"/>
-                <a:satMod val="120000"/>
-                <a:shade val="78000"/>
-              </a:schemeClr>
-            </a:gs>
-          </a:gsLst>
-          <a:lin ang="5400000" scaled="0"/>
-        </a:gradFill>
-      </a:fillStyleLst>
-      <a:lnStyleLst>
-        <a:ln w="6350" cap="flat" cmpd="sng" algn="ctr">
-          <a:solidFill>
-            <a:schemeClr val="phClr"/>
-          </a:solidFill>
-          <a:prstDash val="solid"/>
-          <a:miter lim="800000"/>
-        </a:ln>
-        <a:ln w="12700" cap="flat" cmpd="sng" algn="ctr">
-          <a:solidFill>
-            <a:schemeClr val="phClr"/>
-          </a:solidFill>
-          <a:prstDash val="solid"/>
-          <a:miter lim="800000"/>
-        </a:ln>
-        <a:ln w="19050" cap="flat" cmpd="sng" algn="ctr">
-          <a:solidFill>
-            <a:schemeClr val="phClr"/>
-          </a:solidFill>
-          <a:prstDash val="solid"/>
-          <a:miter lim="800000"/>
-        </a:ln>
-      </a:lnStyleLst>
-      <a:effectStyleLst>
-        <a:effectStyle>
-          <a:effectLst/>
-        </a:effectStyle>
-        <a:effectStyle>
-          <a:effectLst/>
-        </a:effectStyle>
-        <a:effectStyle>
-          <a:effectLst>
-            <a:outerShdw blurRad="57150" dist="19050" dir="5400000" algn="ctr" rotWithShape="0">
-              <a:srgbClr val="000000">
-                <a:alpha val="63000"/>
-              </a:srgbClr>
-            </a:outerShdw>
-          </a:effectLst>
-        </a:effectStyle>
-      </a:effectStyleLst>
-      <a:bgFillStyleLst>
-        <a:solidFill>
-          <a:schemeClr val="phClr"/>
-        </a:solidFill>
-        <a:solidFill>
-          <a:schemeClr val="phClr">
-            <a:tint val="95000"/>
-            <a:satMod val="170000"/>
-          </a:schemeClr>
-        </a:solidFill>
-        <a:gradFill rotWithShape="1">
-          <a:gsLst>
-            <a:gs pos="0">
-              <a:schemeClr val="phClr">
-                <a:tint val="93000"/>
-                <a:satMod val="150000"/>
-                <a:shade val="98000"/>
-                <a:lumMod val="102000"/>
-              </a:schemeClr>
-            </a:gs>
-            <a:gs pos="50000">
-              <a:schemeClr val="phClr">
-                <a:tint val="98000"/>
-                <a:satMod val="130000"/>
-                <a:shade val="90000"/>
-                <a:lumMod val="103000"/>
-              </a:schemeClr>
-            </a:gs>
-            <a:gs pos="100000">
-              <a:schemeClr val="phClr">
-                <a:shade val="63000"/>
-                <a:satMod val="120000"/>
-              </a:schemeClr>
-            </a:gs>
-          </a:gsLst>
-          <a:lin ang="5400000" scaled="0"/>
-        </a:gradFill>
-      </a:bgFillStyleLst>
-    </a:fmtScheme>
-  </a:themeElements>
-  <a:objectDefaults/>
-  <a:extraClrSchemeLst/>
-  <a:extLst>
-    <a:ext uri="{05A4C25C-085E-4340-85A3-A5531E510DB2}">
-      <thm15:themeFamily xmlns:thm15="http://schemas.microsoft.com/office/thememl/2012/main" name="Office Theme" id="{62F939B6-93AF-4DB8-9C6B-D6C7DFDC589F}" vid="{4A3C46E8-61CC-4603-A589-7422A47A8E4A}"/>
-    </a:ext>
-  </a:extLst>
-</a:theme>
-</file>
-
-<file path=ppt/theme/theme3.xml><?xml version="1.0" encoding="utf-8"?>
-<a:theme xmlns:a="http://schemas.openxmlformats.org/drawingml/2006/main" name="Office Theme">
-  <a:themeElements>
-    <a:clrScheme name="Office">
-      <a:dk1>
-        <a:sysClr val="windowText" lastClr="000000"/>
-      </a:dk1>
-      <a:lt1>
-        <a:sysClr val="window" lastClr="FFFFFF"/>
-      </a:lt1>
-      <a:dk2>
-        <a:srgbClr val="44546A"/>
-      </a:dk2>
-      <a:lt2>
-        <a:srgbClr val="E7E6E6"/>
-      </a:lt2>
-      <a:accent1>
-        <a:srgbClr val="4472C4"/>
-      </a:accent1>
-      <a:accent2>
-        <a:srgbClr val="ED7D31"/>
-      </a:accent2>
-      <a:accent3>
-        <a:srgbClr val="A5A5A5"/>
-      </a:accent3>
-      <a:accent4>
-        <a:srgbClr val="FFC000"/>
-      </a:accent4>
-      <a:accent5>
-        <a:srgbClr val="5B9BD5"/>
-      </a:accent5>
-      <a:accent6>
-        <a:srgbClr val="70AD47"/>
-      </a:accent6>
-      <a:hlink>
-        <a:srgbClr val="0563C1"/>
-      </a:hlink>
-      <a:folHlink>
-        <a:srgbClr val="954F72"/>
-      </a:folHlink>
-    </a:clrScheme>
-    <a:fontScheme name="Office">
-      <a:majorFont>
-        <a:latin typeface="Calibri Light" panose="020F0302020204030204"/>
-        <a:ea typeface=""/>
-        <a:cs typeface=""/>
-        <a:font script="Jpan" typeface="游ゴシック Light"/>
-        <a:font script="Hang" typeface="맑은 고딕"/>
-        <a:font script="Hans" typeface="等线 Light"/>
-        <a:font script="Hant" typeface="新細明體"/>
-        <a:font script="Arab" typeface="Times New Roman"/>
-        <a:font script="Hebr" typeface="Times New Roman"/>
-        <a:font script="Thai" typeface="Angsana New"/>
-        <a:font script="Ethi" typeface="Nyala"/>
-        <a:font script="Beng" typeface="Vrinda"/>
-        <a:font script="Gujr" typeface="Shruti"/>
-        <a:font script="Khmr" typeface="MoolBoran"/>
-        <a:font script="Knda" typeface="Tunga"/>
-        <a:font script="Guru" typeface="Raavi"/>
-        <a:font script="Cans" typeface="Euphemia"/>
-        <a:font script="Cher" typeface="Plantagenet Cherokee"/>
-        <a:font script="Yiii" typeface="Microsoft Yi Baiti"/>
-        <a:font script="Tibt" typeface="Microsoft Himalaya"/>
-        <a:font script="Thaa" typeface="MV Boli"/>
-        <a:font script="Deva" typeface="Mangal"/>
-        <a:font script="Telu" typeface="Gautami"/>
-        <a:font script="Taml" typeface="Latha"/>
-        <a:font script="Syrc" typeface="Estrangelo Edessa"/>
-        <a:font script="Orya" typeface="Kalinga"/>
-        <a:font script="Mlym" typeface="Kartika"/>
-        <a:font script="Laoo" typeface="DokChampa"/>
-        <a:font script="Sinh" typeface="Iskoola Pota"/>
-        <a:font script="Mong" typeface="Mongolian Baiti"/>
-        <a:font script="Viet" typeface="Times New Roman"/>
-        <a:font script="Uigh" typeface="Microsoft Uighur"/>
-        <a:font script="Geor" typeface="Sylfaen"/>
-        <a:font script="Armn" typeface="Arial"/>
-        <a:font script="Bugi" typeface="Leelawadee UI"/>
-        <a:font script="Bopo" typeface="Microsoft JhengHei"/>
-        <a:font script="Java" typeface="Javanese Text"/>
-        <a:font script="Lisu" typeface="Segoe UI"/>
-        <a:font script="Mymr" typeface="Myanmar Text"/>
-        <a:font script="Nkoo" typeface="Ebrima"/>
-        <a:font script="Olck" typeface="Nirmala UI"/>
-        <a:font script="Osma" typeface="Ebrima"/>
-        <a:font script="Phag" typeface="Phagspa"/>
-        <a:font script="Syrn" typeface="Estrangelo Edessa"/>
-        <a:font script="Syrj" typeface="Estrangelo Edessa"/>
-        <a:font script="Syre" typeface="Estrangelo Edessa"/>
-        <a:font script="Sora" typeface="Nirmala UI"/>
-        <a:font script="Tale" typeface="Microsoft Tai Le"/>
-        <a:font script="Talu" typeface="Microsoft New Tai Lue"/>
-        <a:font script="Tfng" typeface="Ebrima"/>
-      </a:majorFont>
-      <a:minorFont>
-        <a:latin typeface="Calibri" panose="020F0502020204030204"/>
-        <a:ea typeface=""/>
-        <a:cs typeface=""/>
-        <a:font script="Jpan" typeface="游ゴシック"/>
-        <a:font script="Hang" typeface="맑은 고딕"/>
-        <a:font script="Hans" typeface="等线"/>
-        <a:font script="Hant" typeface="新細明體"/>
-        <a:font script="Arab" typeface="Arial"/>
-        <a:font script="Hebr" typeface="Arial"/>
-        <a:font script="Thai" typeface="Cordia New"/>
-        <a:font script="Ethi" typeface="Nyala"/>
-        <a:font script="Beng" typeface="Vrinda"/>
-        <a:font script="Gujr" typeface="Shruti"/>
-        <a:font script="Khmr" typeface="DaunPenh"/>
-        <a:font script="Knda" typeface="Tunga"/>
-        <a:font script="Guru" typeface="Raavi"/>
-        <a:font script="Cans" typeface="Euphemia"/>
-        <a:font script="Cher" typeface="Plantagenet Cherokee"/>
-        <a:font script="Yiii" typeface="Microsoft Yi Baiti"/>
-        <a:font script="Tibt" typeface="Microsoft Himalaya"/>
-        <a:font script="Thaa" typeface="MV Boli"/>
-        <a:font script="Deva" typeface="Mangal"/>
-        <a:font script="Telu" typeface="Gautami"/>
-        <a:font script="Taml" typeface="Latha"/>
-        <a:font script="Syrc" typeface="Estrangelo Edessa"/>
-        <a:font script="Orya" typeface="Kalinga"/>
-        <a:font script="Mlym" typeface="Kartika"/>
-        <a:font script="Laoo" typeface="DokChampa"/>
-        <a:font script="Sinh" typeface="Iskoola Pota"/>
-        <a:font script="Mong" typeface="Mongolian Baiti"/>
-        <a:font script="Viet" typeface="Arial"/>
-        <a:font script="Uigh" typeface="Microsoft Uighur"/>
-        <a:font script="Geor" typeface="Sylfaen"/>
-        <a:font script="Armn" typeface="Arial"/>
-        <a:font script="Bugi" typeface="Leelawadee UI"/>
-        <a:font script="Bopo" typeface="Microsoft JhengHei"/>
-        <a:font script="Java" typeface="Javanese Text"/>
-        <a:font script="Lisu" typeface="Segoe UI"/>
-        <a:font script="Mymr" typeface="Myanmar Text"/>
-        <a:font script="Nkoo" typeface="Ebrima"/>
-        <a:font script="Olck" typeface="Nirmala UI"/>
-        <a:font script="Osma" typeface="Ebrima"/>
-        <a:font script="Phag" typeface="Phagspa"/>
-        <a:font script="Syrn" typeface="Estrangelo Edessa"/>
-        <a:font script="Syrj" typeface="Estrangelo Edessa"/>
-        <a:font script="Syre" typeface="Estrangelo Edessa"/>
-        <a:font script="Sora" typeface="Nirmala UI"/>
-        <a:font script="Tale" typeface="Microsoft Tai Le"/>
-        <a:font script="Talu" typeface="Microsoft New Tai Lue"/>
-        <a:font script="Tfng" typeface="Ebrima"/>
-      </a:minorFont>
-    </a:fontScheme>
-    <a:fmtScheme name="Office">
-      <a:fillStyleLst>
-        <a:solidFill>
-          <a:schemeClr val="phClr"/>
-        </a:solidFill>
-        <a:gradFill rotWithShape="1">
-          <a:gsLst>
-            <a:gs pos="0">
-              <a:schemeClr val="phClr">
-                <a:lumMod val="110000"/>
-                <a:satMod val="105000"/>
-                <a:tint val="67000"/>
-              </a:schemeClr>
-            </a:gs>
-            <a:gs pos="50000">
-              <a:schemeClr val="phClr">
-                <a:lumMod val="105000"/>
-                <a:satMod val="103000"/>
-                <a:tint val="73000"/>
-              </a:schemeClr>
-            </a:gs>
-            <a:gs pos="100000">
-              <a:schemeClr val="phClr">
-                <a:lumMod val="105000"/>
-                <a:satMod val="109000"/>
-                <a:tint val="81000"/>
-              </a:schemeClr>
-            </a:gs>
-          </a:gsLst>
-          <a:lin ang="5400000" scaled="0"/>
-        </a:gradFill>
-        <a:gradFill rotWithShape="1">
-          <a:gsLst>
-            <a:gs pos="0">
-              <a:schemeClr val="phClr">
-                <a:satMod val="103000"/>
-                <a:lumMod val="102000"/>
-                <a:tint val="94000"/>
-              </a:schemeClr>
-            </a:gs>
-            <a:gs pos="50000">
-              <a:schemeClr val="phClr">
-                <a:satMod val="110000"/>
-                <a:lumMod val="100000"/>
-                <a:shade val="100000"/>
-              </a:schemeClr>
-            </a:gs>
-            <a:gs pos="100000">
-              <a:schemeClr val="phClr">
-                <a:lumMod val="99000"/>
-                <a:satMod val="120000"/>
-                <a:shade val="78000"/>
-              </a:schemeClr>
-            </a:gs>
-          </a:gsLst>
-          <a:lin ang="5400000" scaled="0"/>
-        </a:gradFill>
-      </a:fillStyleLst>
-      <a:lnStyleLst>
-        <a:ln w="6350" cap="flat" cmpd="sng" algn="ctr">
-          <a:solidFill>
-            <a:schemeClr val="phClr"/>
-          </a:solidFill>
-          <a:prstDash val="solid"/>
-          <a:miter lim="800000"/>
-        </a:ln>
-        <a:ln w="12700" cap="flat" cmpd="sng" algn="ctr">
-          <a:solidFill>
-            <a:schemeClr val="phClr"/>
-          </a:solidFill>
-          <a:prstDash val="solid"/>
-          <a:miter lim="800000"/>
-        </a:ln>
-        <a:ln w="19050" cap="flat" cmpd="sng" algn="ctr">
-          <a:solidFill>
-            <a:schemeClr val="phClr"/>
-          </a:solidFill>
-          <a:prstDash val="solid"/>
-          <a:miter lim="800000"/>
-        </a:ln>
-      </a:lnStyleLst>
-      <a:effectStyleLst>
-        <a:effectStyle>
-          <a:effectLst/>
-        </a:effectStyle>
-        <a:effectStyle>
-          <a:effectLst/>
-        </a:effectStyle>
-        <a:effectStyle>
-          <a:effectLst>
-            <a:outerShdw blurRad="57150" dist="19050" dir="5400000" algn="ctr" rotWithShape="0">
-              <a:srgbClr val="000000">
-                <a:alpha val="63000"/>
-              </a:srgbClr>
-            </a:outerShdw>
-          </a:effectLst>
-        </a:effectStyle>
-      </a:effectStyleLst>
-      <a:bgFillStyleLst>
-        <a:solidFill>
-          <a:schemeClr val="phClr"/>
-        </a:solidFill>
-        <a:solidFill>
-          <a:schemeClr val="phClr">
-            <a:tint val="95000"/>
-            <a:satMod val="170000"/>
-          </a:schemeClr>
-        </a:solidFill>
-        <a:gradFill rotWithShape="1">
-          <a:gsLst>
-            <a:gs pos="0">
-              <a:schemeClr val="phClr">
-                <a:tint val="93000"/>
-                <a:satMod val="150000"/>
-                <a:shade val="98000"/>
-                <a:lumMod val="102000"/>
-              </a:schemeClr>
-            </a:gs>
-            <a:gs pos="50000">
-              <a:schemeClr val="phClr">
-                <a:tint val="98000"/>
-                <a:satMod val="130000"/>
-                <a:shade val="90000"/>
-                <a:lumMod val="103000"/>
-              </a:schemeClr>
-            </a:gs>
-            <a:gs pos="100000">
-              <a:schemeClr val="phClr">
-                <a:shade val="63000"/>
-                <a:satMod val="120000"/>
-              </a:schemeClr>
-            </a:gs>
-          </a:gsLst>
-          <a:lin ang="5400000" scaled="0"/>
-        </a:gradFill>
-      </a:bgFillStyleLst>
-    </a:fmtScheme>
-  </a:themeElements>
-  <a:objectDefaults/>
-  <a:extraClrSchemeLst/>
-  <a:extLst>
-    <a:ext uri="{05A4C25C-085E-4340-85A3-A5531E510DB2}">
-      <thm15:themeFamily xmlns:thm15="http://schemas.microsoft.com/office/thememl/2012/main" name="Office Theme" id="{62F939B6-93AF-4DB8-9C6B-D6C7DFDC589F}" vid="{4A3C46E8-61CC-4603-A589-7422A47A8E4A}"/>
-    </a:ext>
-  </a:extLst>
-</a:theme>
 </file>
</xml_diff>

<commit_message>
chore(template): update default PPTX master template
Replace default-pptx-master.pptx with updated version and keep old
copy as _default-pptx-master.pptx for reference.

Made-with: Cursor
</commit_message>
<xml_diff>
--- a/backend/assets/default-pptx-master.pptx
+++ b/backend/assets/default-pptx-master.pptx
@@ -15,6 +15,9 @@
   </p:sldIdLst>
   <p:sldSz cx="12192000" cy="6858000"/>
   <p:notesSz cx="6858000" cy="9144000"/>
+  <p:custDataLst>
+    <p:tags r:id="rId5"/>
+  </p:custDataLst>
   <p:defaultTextStyle>
     <a:defPPr>
       <a:defRPr lang="en-US"/>
@@ -113,6 +116,14 @@
 </p:presentation>
 </file>
 
+<file path=ppt/revisionInfo.xml><?xml version="1.0" encoding="utf-8"?>
+<p1510:revInfo xmlns:a="http://schemas.openxmlformats.org/drawingml/2006/main" xmlns:r="http://schemas.openxmlformats.org/officeDocument/2006/relationships" xmlns:p1510="http://schemas.microsoft.com/office/powerpoint/2015/10/main">
+  <p1510:revLst>
+    <p1510:client id="{AE169B9A-A09C-4DEA-A22B-FC8AD0ED9A4E}" v="2" dt="2026-03-24T16:17:49.330"/>
+  </p1510:revLst>
+</p1510:revInfo>
+</file>
+
 <file path=ppt/handoutMasters/handoutMaster1.xml><?xml version="1.0" encoding="utf-8"?>
 <p:handoutMaster xmlns:a="http://schemas.openxmlformats.org/drawingml/2006/main" xmlns:r="http://schemas.openxmlformats.org/officeDocument/2006/relationships" xmlns:p="http://schemas.openxmlformats.org/presentationml/2006/main">
   <p:cSld>
@@ -207,7 +218,7 @@
           <a:p>
             <a:fld id="{5A77F5BE-1060-450B-A36E-276A6E22C534}" type="datetimeFigureOut">
               <a:rPr lang="en-US" smtClean="0"/>
-              <a:t>3/24/2026</a:t>
+              <a:t>4/16/26</a:t>
             </a:fld>
             <a:endParaRPr lang="en-US"/>
           </a:p>
@@ -384,7 +395,7 @@
           <a:p>
             <a:fld id="{481AEA91-D21D-4AC7-B9CB-0DE24671E4AD}" type="datetimeFigureOut">
               <a:rPr lang="en-US" smtClean="0"/>
-              <a:t>3/24/2026</a:t>
+              <a:t>4/16/26</a:t>
             </a:fld>
             <a:endParaRPr lang="en-US"/>
           </a:p>
@@ -668,6 +679,78 @@
           <a:chExt cx="0" cy="0"/>
         </a:xfrm>
       </p:grpSpPr>
+      <p:graphicFrame>
+        <p:nvGraphicFramePr>
+          <p:cNvPr id="8" name="Object 7" hidden="1">
+            <a:extLst>
+              <a:ext uri="{FF2B5EF4-FFF2-40B4-BE49-F238E27FC236}">
+                <a16:creationId xmlns:a16="http://schemas.microsoft.com/office/drawing/2014/main" id="{1E74CF8E-7A35-42FD-94D9-646327B4F2FF}"/>
+              </a:ext>
+            </a:extLst>
+          </p:cNvPr>
+          <p:cNvGraphicFramePr>
+            <a:graphicFrameLocks noChangeAspect="1"/>
+          </p:cNvGraphicFramePr>
+          <p:nvPr userDrawn="1">
+            <p:custDataLst>
+              <p:tags r:id="rId1"/>
+            </p:custDataLst>
+            <p:extLst>
+              <p:ext uri="{D42A27DB-BD31-4B8C-83A1-F6EECF244321}">
+                <p14:modId xmlns:p14="http://schemas.microsoft.com/office/powerpoint/2010/main" val="421810460"/>
+              </p:ext>
+            </p:extLst>
+          </p:nvPr>
+        </p:nvGraphicFramePr>
+        <p:xfrm>
+          <a:off x="1588" y="1588"/>
+          <a:ext cx="1588" cy="1588"/>
+        </p:xfrm>
+        <a:graphic>
+          <a:graphicData uri="http://schemas.openxmlformats.org/presentationml/2006/ole">
+            <mc:AlternateContent xmlns:mc="http://schemas.openxmlformats.org/markup-compatibility/2006">
+              <mc:Choice xmlns:v="urn:schemas-microsoft-com:vml" Requires="v">
+                <p:oleObj name="think-cell Slide" r:id="rId3" imgW="473" imgH="473" progId="TCLayout.ActiveDocument.1">
+                  <p:embed/>
+                </p:oleObj>
+              </mc:Choice>
+              <mc:Fallback>
+                <p:oleObj name="think-cell Slide" r:id="rId3" imgW="473" imgH="473" progId="TCLayout.ActiveDocument.1">
+                  <p:embed/>
+                  <p:pic>
+                    <p:nvPicPr>
+                      <p:cNvPr id="8" name="Object 7" hidden="1">
+                        <a:extLst>
+                          <a:ext uri="{FF2B5EF4-FFF2-40B4-BE49-F238E27FC236}">
+                            <a16:creationId xmlns:a16="http://schemas.microsoft.com/office/drawing/2014/main" id="{1E74CF8E-7A35-42FD-94D9-646327B4F2FF}"/>
+                          </a:ext>
+                        </a:extLst>
+                      </p:cNvPr>
+                      <p:cNvPicPr/>
+                      <p:nvPr/>
+                    </p:nvPicPr>
+                    <p:blipFill>
+                      <a:blip r:embed="rId4"/>
+                      <a:stretch>
+                        <a:fillRect/>
+                      </a:stretch>
+                    </p:blipFill>
+                    <p:spPr>
+                      <a:xfrm>
+                        <a:off x="1588" y="1588"/>
+                        <a:ext cx="1588" cy="1588"/>
+                      </a:xfrm>
+                      <a:prstGeom prst="rect">
+                        <a:avLst/>
+                      </a:prstGeom>
+                    </p:spPr>
+                  </p:pic>
+                </p:oleObj>
+              </mc:Fallback>
+            </mc:AlternateContent>
+          </a:graphicData>
+        </a:graphic>
+      </p:graphicFrame>
       <p:sp>
         <p:nvSpPr>
           <p:cNvPr id="7" name="Title">
@@ -1090,6 +1173,66 @@
           <a:chExt cx="0" cy="0"/>
         </a:xfrm>
       </p:grpSpPr>
+      <p:graphicFrame>
+        <p:nvGraphicFramePr>
+          <p:cNvPr id="8" name="Object 7" hidden="1"/>
+          <p:cNvGraphicFramePr>
+            <a:graphicFrameLocks noChangeAspect="1"/>
+          </p:cNvGraphicFramePr>
+          <p:nvPr userDrawn="1">
+            <p:custDataLst>
+              <p:tags r:id="rId3"/>
+            </p:custDataLst>
+            <p:extLst>
+              <p:ext uri="{D42A27DB-BD31-4B8C-83A1-F6EECF244321}">
+                <p14:modId xmlns:p14="http://schemas.microsoft.com/office/powerpoint/2010/main" val="3586046917"/>
+              </p:ext>
+            </p:extLst>
+          </p:nvPr>
+        </p:nvGraphicFramePr>
+        <p:xfrm>
+          <a:off x="1927" y="1408"/>
+          <a:ext cx="1924" cy="1401"/>
+        </p:xfrm>
+        <a:graphic>
+          <a:graphicData uri="http://schemas.openxmlformats.org/presentationml/2006/ole">
+            <mc:AlternateContent xmlns:mc="http://schemas.openxmlformats.org/markup-compatibility/2006">
+              <mc:Choice xmlns:v="urn:schemas-microsoft-com:vml" Requires="v">
+                <p:oleObj name="think-cell Slide" r:id="rId5" imgW="415" imgH="416" progId="TCLayout.ActiveDocument.1">
+                  <p:embed/>
+                </p:oleObj>
+              </mc:Choice>
+              <mc:Fallback>
+                <p:oleObj name="think-cell Slide" r:id="rId5" imgW="415" imgH="416" progId="TCLayout.ActiveDocument.1">
+                  <p:embed/>
+                  <p:pic>
+                    <p:nvPicPr>
+                      <p:cNvPr id="8" name="Object 7" hidden="1"/>
+                      <p:cNvPicPr/>
+                      <p:nvPr/>
+                    </p:nvPicPr>
+                    <p:blipFill>
+                      <a:blip r:embed="rId6"/>
+                      <a:stretch>
+                        <a:fillRect/>
+                      </a:stretch>
+                    </p:blipFill>
+                    <p:spPr>
+                      <a:xfrm>
+                        <a:off x="1927" y="1408"/>
+                        <a:ext cx="1924" cy="1401"/>
+                      </a:xfrm>
+                      <a:prstGeom prst="rect">
+                        <a:avLst/>
+                      </a:prstGeom>
+                    </p:spPr>
+                  </p:pic>
+                </p:oleObj>
+              </mc:Fallback>
+            </mc:AlternateContent>
+          </a:graphicData>
+        </a:graphic>
+      </p:graphicFrame>
       <p:sp>
         <p:nvSpPr>
           <p:cNvPr id="7" name="Rectangle 6" hidden="1"/>
@@ -2034,6 +2177,32 @@
 </p:sld>
 </file>
 
+<file path=ppt/tags/tag1.xml><?xml version="1.0" encoding="utf-8"?>
+<p:tagLst xmlns:a="http://schemas.openxmlformats.org/drawingml/2006/main" xmlns:r="http://schemas.openxmlformats.org/officeDocument/2006/relationships" xmlns:p="http://schemas.openxmlformats.org/presentationml/2006/main">
+  <p:tag name="THINKCELLPRESENTATIONDONOTDELETE" val="&lt;?xml version=&quot;1.0&quot; encoding=&quot;UTF-16&quot; standalone=&quot;yes&quot;?&gt;&lt;root reqver=&quot;27037&quot;&gt;&lt;version val=&quot;32852&quot;/&gt;&lt;CPresentation id=&quot;1&quot;&gt;&lt;m_precDefaultNumber&gt;&lt;m_bNumberIsYear val=&quot;1&quot;/&gt;&lt;m_chMinusSymbol&gt;-&lt;/m_chMinusSymbol&gt;&lt;m_chDecimalSymbol17909&gt;.&lt;/m_chDecimalSymbol17909&gt;&lt;m_nGroupingDigits17909 val=&quot;3&quot;/&gt;&lt;m_chGroupingSymbol17909&gt;,&lt;/m_chGroupingSymbol17909&gt;&lt;m_yearfmt&gt;&lt;begin val=&quot;0&quot;/&gt;&lt;end val=&quot;4&quot;/&gt;&lt;/m_yearfmt&gt;&lt;/m_precDefaultNumber&gt;&lt;m_precDefaultPercent&gt;&lt;m_bNumberIsYear val=&quot;1&quot;/&gt;&lt;m_chMinusSymbol&gt;-&lt;/m_chMinusSymbol&gt;&lt;m_nDecimalDigits17909 val=&quot;0&quot;/&gt;&lt;m_chDecimalSymbol17909&gt;.&lt;/m_chDecimalSymbol17909&gt;&lt;m_nGroupingDigits17909 val=&quot;3&quot;/&gt;&lt;m_chGroupingSymbol17909&gt;,&lt;/m_chGroupingSymbol17909&gt;&lt;m_strSuffix17909&gt;%&lt;/m_strSuffix17909&gt;&lt;m_yearfmt&gt;&lt;begin val=&quot;0&quot;/&gt;&lt;end val=&quot;4&quot;/&gt;&lt;/m_yearfmt&gt;&lt;/m_precDefaultPercent&gt;&lt;m_precDefaultDate&gt;&lt;m_bNumberIsYear val=&quot;0&quot;/&gt;&lt;m_strFormatTime&gt;%#m/%#d&lt;/m_strFormatTime&gt;&lt;m_yearfmt&gt;&lt;begin val=&quot;0&quot;/&gt;&lt;end val=&quot;0&quot;/&gt;&lt;/m_yearfmt&gt;&lt;/m_precDefaultDate&gt;&lt;m_precDefaultDay&gt;&lt;m_bNumberIsYear val=&quot;0&quot;/&gt;&lt;m_strFormatTime&gt;%#d&lt;/m_strFormatTime&gt;&lt;m_yearfmt&gt;&lt;begin val=&quot;0&quot;/&gt;&lt;end val=&quot;4&quot;/&gt;&lt;/m_yearfmt&gt;&lt;/m_precDefaultDay&gt;&lt;m_precDefaultWeek&gt;&lt;m_yearfmt&gt;&lt;begin val=&quot;0&quot;/&gt;&lt;end val=&quot;4&quot;/&gt;&lt;/m_yearfmt&gt;&lt;/m_precDefaultWeek&gt;&lt;m_precDefaultMonth&gt;&lt;m_bNumberIsYear val=&quot;0&quot;/&gt;&lt;m_strFormatTime&gt;%1&lt;/m_strFormatTime&gt;&lt;m_yearfmt&gt;&lt;begin val=&quot;0&quot;/&gt;&lt;end val=&quot;4&quot;/&gt;&lt;/m_yearfmt&gt;&lt;/m_precDefaultMonth&gt;&lt;m_precDefaultQuarter&gt;&lt;m_bNumberIsYear val=&quot;0&quot;/&gt;&lt;m_strFormatTime&gt;Q%5&lt;/m_strFormatTime&gt;&lt;m_yearfmt&gt;&lt;begin val=&quot;0&quot;/&gt;&lt;end val=&quot;4&quot;/&gt;&lt;/m_yearfmt&gt;&lt;/m_precDefaultQuarter&gt;&lt;m_precDefaultYear&gt;&lt;m_bNumberIsYear val=&quot;0&quot;/&gt;&lt;m_strFormatTime&gt;%Y&lt;/m_strFormatTime&gt;&lt;m_yearfmt&gt;&lt;begin val=&quot;0&quot;/&gt;&lt;end val=&quot;0&quot;/&gt;&lt;/m_yearfmt&gt;&lt;/m_precDefaultYear&gt;&lt;m_precDefaultFYDay&gt;&lt;m_yearfmt&gt;&lt;begin val=&quot;0&quot;/&gt;&lt;end val=&quot;4&quot;/&gt;&lt;/m_yearfmt&gt;&lt;/m_precDefaultFYDay&gt;&lt;m_precDefaultFYWeek&gt;&lt;m_yearfmt&gt;&lt;begin val=&quot;0&quot;/&gt;&lt;end val=&quot;4&quot;/&gt;&lt;/m_yearfmt&gt;&lt;/m_precDefaultFYWeek&gt;&lt;m_precDefaultFYMonth&gt;&lt;m_yearfmt&gt;&lt;begin val=&quot;0&quot;/&gt;&lt;end val=&quot;4&quot;/&gt;&lt;/m_yearfmt&gt;&lt;/m_precDefaultFYMonth&gt;&lt;m_precDefaultFYQuarter&gt;&lt;m_yearfmt&gt;&lt;begin val=&quot;0&quot;/&gt;&lt;end val=&quot;4&quot;/&gt;&lt;/m_yearfmt&gt;&lt;/m_precDefaultFYQuarter&gt;&lt;m_precDefaultFYYear&gt;&lt;m_yearfmt&gt;&lt;begin val=&quot;0&quot;/&gt;&lt;end val=&quot;4&quot;/&gt;&lt;/m_yearfmt&gt;&lt;/m_precDefaultFYYear&gt;&lt;m_mruColor&gt;&lt;m_vecMRU length=&quot;2&quot;&gt;&lt;elem m_fUsage=&quot;2.70999999999999996447E+00&quot;&gt;&lt;m_msothmcolidx val=&quot;0&quot;/&gt;&lt;m_rgb r=&quot;F9&quot; g=&quot;62&quot; b=&quot;12&quot;/&gt;&lt;/elem&gt;&lt;elem m_fUsage=&quot;7.29000000000000092371E-01&quot;&gt;&lt;m_msothmcolidx val=&quot;0&quot;/&gt;&lt;m_rgb r=&quot;DA&quot; g=&quot;DA&quot; b=&quot;DA&quot;/&gt;&lt;/elem&gt;&lt;/m_vecMRU&gt;&lt;/m_mruColor&gt;&lt;m_eweekdayFirstOfWeek val=&quot;2&quot;/&gt;&lt;m_eweekdayFirstOfWorkweek val=&quot;1&quot;/&gt;&lt;m_eweekdayFirstOfWeekend val=&quot;6&quot;/&gt;&lt;/CPresentation&gt;&lt;/root&gt;"/>
+  <p:tag name="THINKCELLUNDODONOTDELETE" val="0"/>
+  <p:tag name="LASTSLIDEVIEWED" val="2147479891,24,Our approach consists of four main pillars"/>
+</p:tagLst>
+</file>
+
+<file path=ppt/tags/tag2.xml><?xml version="1.0" encoding="utf-8"?>
+<p:tagLst xmlns:a="http://schemas.openxmlformats.org/drawingml/2006/main" xmlns:r="http://schemas.openxmlformats.org/officeDocument/2006/relationships" xmlns:p="http://schemas.openxmlformats.org/presentationml/2006/main">
+  <p:tag name="THINKCELLSHAPEDONOTDELETE" val="thinkcellActiveDocDoNotDelete"/>
+</p:tagLst>
+</file>
+
+<file path=ppt/tags/tag3.xml><?xml version="1.0" encoding="utf-8"?>
+<p:tagLst xmlns:a="http://schemas.openxmlformats.org/drawingml/2006/main" xmlns:r="http://schemas.openxmlformats.org/officeDocument/2006/relationships" xmlns:p="http://schemas.openxmlformats.org/presentationml/2006/main">
+  <p:tag name="THINKCELLSHAPEDONOTDELETE" val="tPuUx_gg7jMOGCXTSUL3Ogw"/>
+</p:tagLst>
+</file>
+
+<file path=ppt/tags/tag4.xml><?xml version="1.0" encoding="utf-8"?>
+<p:tagLst xmlns:a="http://schemas.openxmlformats.org/drawingml/2006/main" xmlns:r="http://schemas.openxmlformats.org/officeDocument/2006/relationships" xmlns:p="http://schemas.openxmlformats.org/presentationml/2006/main">
+  <p:tag name="THINKCELLSHAPEDONOTDELETE" val="thinkcellActiveDocDoNotDelete"/>
+</p:tagLst>
+</file>
+
 <file path=ppt/theme/theme1.xml><?xml version="1.0" encoding="utf-8"?>
 <a:theme xmlns:a="http://schemas.openxmlformats.org/drawingml/2006/main" name="Widescreen 16x9 Template">
   <a:themeElements>
@@ -2332,4 +2501,594 @@
     </a:ext>
   </a:extLst>
 </a:theme>
+</file>
+
+<file path=ppt/theme/theme2.xml><?xml version="1.0" encoding="utf-8"?>
+<a:theme xmlns:a="http://schemas.openxmlformats.org/drawingml/2006/main" name="Office Theme">
+  <a:themeElements>
+    <a:clrScheme name="Office">
+      <a:dk1>
+        <a:sysClr val="windowText" lastClr="000000"/>
+      </a:dk1>
+      <a:lt1>
+        <a:sysClr val="window" lastClr="FFFFFF"/>
+      </a:lt1>
+      <a:dk2>
+        <a:srgbClr val="44546A"/>
+      </a:dk2>
+      <a:lt2>
+        <a:srgbClr val="E7E6E6"/>
+      </a:lt2>
+      <a:accent1>
+        <a:srgbClr val="4472C4"/>
+      </a:accent1>
+      <a:accent2>
+        <a:srgbClr val="ED7D31"/>
+      </a:accent2>
+      <a:accent3>
+        <a:srgbClr val="A5A5A5"/>
+      </a:accent3>
+      <a:accent4>
+        <a:srgbClr val="FFC000"/>
+      </a:accent4>
+      <a:accent5>
+        <a:srgbClr val="5B9BD5"/>
+      </a:accent5>
+      <a:accent6>
+        <a:srgbClr val="70AD47"/>
+      </a:accent6>
+      <a:hlink>
+        <a:srgbClr val="0563C1"/>
+      </a:hlink>
+      <a:folHlink>
+        <a:srgbClr val="954F72"/>
+      </a:folHlink>
+    </a:clrScheme>
+    <a:fontScheme name="Office">
+      <a:majorFont>
+        <a:latin typeface="Calibri Light" panose="020F0302020204030204"/>
+        <a:ea typeface=""/>
+        <a:cs typeface=""/>
+        <a:font script="Jpan" typeface="游ゴシック Light"/>
+        <a:font script="Hang" typeface="맑은 고딕"/>
+        <a:font script="Hans" typeface="等线 Light"/>
+        <a:font script="Hant" typeface="新細明體"/>
+        <a:font script="Arab" typeface="Times New Roman"/>
+        <a:font script="Hebr" typeface="Times New Roman"/>
+        <a:font script="Thai" typeface="Angsana New"/>
+        <a:font script="Ethi" typeface="Nyala"/>
+        <a:font script="Beng" typeface="Vrinda"/>
+        <a:font script="Gujr" typeface="Shruti"/>
+        <a:font script="Khmr" typeface="MoolBoran"/>
+        <a:font script="Knda" typeface="Tunga"/>
+        <a:font script="Guru" typeface="Raavi"/>
+        <a:font script="Cans" typeface="Euphemia"/>
+        <a:font script="Cher" typeface="Plantagenet Cherokee"/>
+        <a:font script="Yiii" typeface="Microsoft Yi Baiti"/>
+        <a:font script="Tibt" typeface="Microsoft Himalaya"/>
+        <a:font script="Thaa" typeface="MV Boli"/>
+        <a:font script="Deva" typeface="Mangal"/>
+        <a:font script="Telu" typeface="Gautami"/>
+        <a:font script="Taml" typeface="Latha"/>
+        <a:font script="Syrc" typeface="Estrangelo Edessa"/>
+        <a:font script="Orya" typeface="Kalinga"/>
+        <a:font script="Mlym" typeface="Kartika"/>
+        <a:font script="Laoo" typeface="DokChampa"/>
+        <a:font script="Sinh" typeface="Iskoola Pota"/>
+        <a:font script="Mong" typeface="Mongolian Baiti"/>
+        <a:font script="Viet" typeface="Times New Roman"/>
+        <a:font script="Uigh" typeface="Microsoft Uighur"/>
+        <a:font script="Geor" typeface="Sylfaen"/>
+        <a:font script="Armn" typeface="Arial"/>
+        <a:font script="Bugi" typeface="Leelawadee UI"/>
+        <a:font script="Bopo" typeface="Microsoft JhengHei"/>
+        <a:font script="Java" typeface="Javanese Text"/>
+        <a:font script="Lisu" typeface="Segoe UI"/>
+        <a:font script="Mymr" typeface="Myanmar Text"/>
+        <a:font script="Nkoo" typeface="Ebrima"/>
+        <a:font script="Olck" typeface="Nirmala UI"/>
+        <a:font script="Osma" typeface="Ebrima"/>
+        <a:font script="Phag" typeface="Phagspa"/>
+        <a:font script="Syrn" typeface="Estrangelo Edessa"/>
+        <a:font script="Syrj" typeface="Estrangelo Edessa"/>
+        <a:font script="Syre" typeface="Estrangelo Edessa"/>
+        <a:font script="Sora" typeface="Nirmala UI"/>
+        <a:font script="Tale" typeface="Microsoft Tai Le"/>
+        <a:font script="Talu" typeface="Microsoft New Tai Lue"/>
+        <a:font script="Tfng" typeface="Ebrima"/>
+      </a:majorFont>
+      <a:minorFont>
+        <a:latin typeface="Calibri" panose="020F0502020204030204"/>
+        <a:ea typeface=""/>
+        <a:cs typeface=""/>
+        <a:font script="Jpan" typeface="游ゴシック"/>
+        <a:font script="Hang" typeface="맑은 고딕"/>
+        <a:font script="Hans" typeface="等线"/>
+        <a:font script="Hant" typeface="新細明體"/>
+        <a:font script="Arab" typeface="Arial"/>
+        <a:font script="Hebr" typeface="Arial"/>
+        <a:font script="Thai" typeface="Cordia New"/>
+        <a:font script="Ethi" typeface="Nyala"/>
+        <a:font script="Beng" typeface="Vrinda"/>
+        <a:font script="Gujr" typeface="Shruti"/>
+        <a:font script="Khmr" typeface="DaunPenh"/>
+        <a:font script="Knda" typeface="Tunga"/>
+        <a:font script="Guru" typeface="Raavi"/>
+        <a:font script="Cans" typeface="Euphemia"/>
+        <a:font script="Cher" typeface="Plantagenet Cherokee"/>
+        <a:font script="Yiii" typeface="Microsoft Yi Baiti"/>
+        <a:font script="Tibt" typeface="Microsoft Himalaya"/>
+        <a:font script="Thaa" typeface="MV Boli"/>
+        <a:font script="Deva" typeface="Mangal"/>
+        <a:font script="Telu" typeface="Gautami"/>
+        <a:font script="Taml" typeface="Latha"/>
+        <a:font script="Syrc" typeface="Estrangelo Edessa"/>
+        <a:font script="Orya" typeface="Kalinga"/>
+        <a:font script="Mlym" typeface="Kartika"/>
+        <a:font script="Laoo" typeface="DokChampa"/>
+        <a:font script="Sinh" typeface="Iskoola Pota"/>
+        <a:font script="Mong" typeface="Mongolian Baiti"/>
+        <a:font script="Viet" typeface="Arial"/>
+        <a:font script="Uigh" typeface="Microsoft Uighur"/>
+        <a:font script="Geor" typeface="Sylfaen"/>
+        <a:font script="Armn" typeface="Arial"/>
+        <a:font script="Bugi" typeface="Leelawadee UI"/>
+        <a:font script="Bopo" typeface="Microsoft JhengHei"/>
+        <a:font script="Java" typeface="Javanese Text"/>
+        <a:font script="Lisu" typeface="Segoe UI"/>
+        <a:font script="Mymr" typeface="Myanmar Text"/>
+        <a:font script="Nkoo" typeface="Ebrima"/>
+        <a:font script="Olck" typeface="Nirmala UI"/>
+        <a:font script="Osma" typeface="Ebrima"/>
+        <a:font script="Phag" typeface="Phagspa"/>
+        <a:font script="Syrn" typeface="Estrangelo Edessa"/>
+        <a:font script="Syrj" typeface="Estrangelo Edessa"/>
+        <a:font script="Syre" typeface="Estrangelo Edessa"/>
+        <a:font script="Sora" typeface="Nirmala UI"/>
+        <a:font script="Tale" typeface="Microsoft Tai Le"/>
+        <a:font script="Talu" typeface="Microsoft New Tai Lue"/>
+        <a:font script="Tfng" typeface="Ebrima"/>
+      </a:minorFont>
+    </a:fontScheme>
+    <a:fmtScheme name="Office">
+      <a:fillStyleLst>
+        <a:solidFill>
+          <a:schemeClr val="phClr"/>
+        </a:solidFill>
+        <a:gradFill rotWithShape="1">
+          <a:gsLst>
+            <a:gs pos="0">
+              <a:schemeClr val="phClr">
+                <a:lumMod val="110000"/>
+                <a:satMod val="105000"/>
+                <a:tint val="67000"/>
+              </a:schemeClr>
+            </a:gs>
+            <a:gs pos="50000">
+              <a:schemeClr val="phClr">
+                <a:lumMod val="105000"/>
+                <a:satMod val="103000"/>
+                <a:tint val="73000"/>
+              </a:schemeClr>
+            </a:gs>
+            <a:gs pos="100000">
+              <a:schemeClr val="phClr">
+                <a:lumMod val="105000"/>
+                <a:satMod val="109000"/>
+                <a:tint val="81000"/>
+              </a:schemeClr>
+            </a:gs>
+          </a:gsLst>
+          <a:lin ang="5400000" scaled="0"/>
+        </a:gradFill>
+        <a:gradFill rotWithShape="1">
+          <a:gsLst>
+            <a:gs pos="0">
+              <a:schemeClr val="phClr">
+                <a:satMod val="103000"/>
+                <a:lumMod val="102000"/>
+                <a:tint val="94000"/>
+              </a:schemeClr>
+            </a:gs>
+            <a:gs pos="50000">
+              <a:schemeClr val="phClr">
+                <a:satMod val="110000"/>
+                <a:lumMod val="100000"/>
+                <a:shade val="100000"/>
+              </a:schemeClr>
+            </a:gs>
+            <a:gs pos="100000">
+              <a:schemeClr val="phClr">
+                <a:lumMod val="99000"/>
+                <a:satMod val="120000"/>
+                <a:shade val="78000"/>
+              </a:schemeClr>
+            </a:gs>
+          </a:gsLst>
+          <a:lin ang="5400000" scaled="0"/>
+        </a:gradFill>
+      </a:fillStyleLst>
+      <a:lnStyleLst>
+        <a:ln w="6350" cap="flat" cmpd="sng" algn="ctr">
+          <a:solidFill>
+            <a:schemeClr val="phClr"/>
+          </a:solidFill>
+          <a:prstDash val="solid"/>
+          <a:miter lim="800000"/>
+        </a:ln>
+        <a:ln w="12700" cap="flat" cmpd="sng" algn="ctr">
+          <a:solidFill>
+            <a:schemeClr val="phClr"/>
+          </a:solidFill>
+          <a:prstDash val="solid"/>
+          <a:miter lim="800000"/>
+        </a:ln>
+        <a:ln w="19050" cap="flat" cmpd="sng" algn="ctr">
+          <a:solidFill>
+            <a:schemeClr val="phClr"/>
+          </a:solidFill>
+          <a:prstDash val="solid"/>
+          <a:miter lim="800000"/>
+        </a:ln>
+      </a:lnStyleLst>
+      <a:effectStyleLst>
+        <a:effectStyle>
+          <a:effectLst/>
+        </a:effectStyle>
+        <a:effectStyle>
+          <a:effectLst/>
+        </a:effectStyle>
+        <a:effectStyle>
+          <a:effectLst>
+            <a:outerShdw blurRad="57150" dist="19050" dir="5400000" algn="ctr" rotWithShape="0">
+              <a:srgbClr val="000000">
+                <a:alpha val="63000"/>
+              </a:srgbClr>
+            </a:outerShdw>
+          </a:effectLst>
+        </a:effectStyle>
+      </a:effectStyleLst>
+      <a:bgFillStyleLst>
+        <a:solidFill>
+          <a:schemeClr val="phClr"/>
+        </a:solidFill>
+        <a:solidFill>
+          <a:schemeClr val="phClr">
+            <a:tint val="95000"/>
+            <a:satMod val="170000"/>
+          </a:schemeClr>
+        </a:solidFill>
+        <a:gradFill rotWithShape="1">
+          <a:gsLst>
+            <a:gs pos="0">
+              <a:schemeClr val="phClr">
+                <a:tint val="93000"/>
+                <a:satMod val="150000"/>
+                <a:shade val="98000"/>
+                <a:lumMod val="102000"/>
+              </a:schemeClr>
+            </a:gs>
+            <a:gs pos="50000">
+              <a:schemeClr val="phClr">
+                <a:tint val="98000"/>
+                <a:satMod val="130000"/>
+                <a:shade val="90000"/>
+                <a:lumMod val="103000"/>
+              </a:schemeClr>
+            </a:gs>
+            <a:gs pos="100000">
+              <a:schemeClr val="phClr">
+                <a:shade val="63000"/>
+                <a:satMod val="120000"/>
+              </a:schemeClr>
+            </a:gs>
+          </a:gsLst>
+          <a:lin ang="5400000" scaled="0"/>
+        </a:gradFill>
+      </a:bgFillStyleLst>
+    </a:fmtScheme>
+  </a:themeElements>
+  <a:objectDefaults/>
+  <a:extraClrSchemeLst/>
+  <a:extLst>
+    <a:ext uri="{05A4C25C-085E-4340-85A3-A5531E510DB2}">
+      <thm15:themeFamily xmlns:thm15="http://schemas.microsoft.com/office/thememl/2012/main" name="Office Theme" id="{62F939B6-93AF-4DB8-9C6B-D6C7DFDC589F}" vid="{4A3C46E8-61CC-4603-A589-7422A47A8E4A}"/>
+    </a:ext>
+  </a:extLst>
+</a:theme>
+</file>
+
+<file path=ppt/theme/theme3.xml><?xml version="1.0" encoding="utf-8"?>
+<a:theme xmlns:a="http://schemas.openxmlformats.org/drawingml/2006/main" name="Office Theme">
+  <a:themeElements>
+    <a:clrScheme name="Office">
+      <a:dk1>
+        <a:sysClr val="windowText" lastClr="000000"/>
+      </a:dk1>
+      <a:lt1>
+        <a:sysClr val="window" lastClr="FFFFFF"/>
+      </a:lt1>
+      <a:dk2>
+        <a:srgbClr val="44546A"/>
+      </a:dk2>
+      <a:lt2>
+        <a:srgbClr val="E7E6E6"/>
+      </a:lt2>
+      <a:accent1>
+        <a:srgbClr val="4472C4"/>
+      </a:accent1>
+      <a:accent2>
+        <a:srgbClr val="ED7D31"/>
+      </a:accent2>
+      <a:accent3>
+        <a:srgbClr val="A5A5A5"/>
+      </a:accent3>
+      <a:accent4>
+        <a:srgbClr val="FFC000"/>
+      </a:accent4>
+      <a:accent5>
+        <a:srgbClr val="5B9BD5"/>
+      </a:accent5>
+      <a:accent6>
+        <a:srgbClr val="70AD47"/>
+      </a:accent6>
+      <a:hlink>
+        <a:srgbClr val="0563C1"/>
+      </a:hlink>
+      <a:folHlink>
+        <a:srgbClr val="954F72"/>
+      </a:folHlink>
+    </a:clrScheme>
+    <a:fontScheme name="Office">
+      <a:majorFont>
+        <a:latin typeface="Calibri Light" panose="020F0302020204030204"/>
+        <a:ea typeface=""/>
+        <a:cs typeface=""/>
+        <a:font script="Jpan" typeface="游ゴシック Light"/>
+        <a:font script="Hang" typeface="맑은 고딕"/>
+        <a:font script="Hans" typeface="等线 Light"/>
+        <a:font script="Hant" typeface="新細明體"/>
+        <a:font script="Arab" typeface="Times New Roman"/>
+        <a:font script="Hebr" typeface="Times New Roman"/>
+        <a:font script="Thai" typeface="Angsana New"/>
+        <a:font script="Ethi" typeface="Nyala"/>
+        <a:font script="Beng" typeface="Vrinda"/>
+        <a:font script="Gujr" typeface="Shruti"/>
+        <a:font script="Khmr" typeface="MoolBoran"/>
+        <a:font script="Knda" typeface="Tunga"/>
+        <a:font script="Guru" typeface="Raavi"/>
+        <a:font script="Cans" typeface="Euphemia"/>
+        <a:font script="Cher" typeface="Plantagenet Cherokee"/>
+        <a:font script="Yiii" typeface="Microsoft Yi Baiti"/>
+        <a:font script="Tibt" typeface="Microsoft Himalaya"/>
+        <a:font script="Thaa" typeface="MV Boli"/>
+        <a:font script="Deva" typeface="Mangal"/>
+        <a:font script="Telu" typeface="Gautami"/>
+        <a:font script="Taml" typeface="Latha"/>
+        <a:font script="Syrc" typeface="Estrangelo Edessa"/>
+        <a:font script="Orya" typeface="Kalinga"/>
+        <a:font script="Mlym" typeface="Kartika"/>
+        <a:font script="Laoo" typeface="DokChampa"/>
+        <a:font script="Sinh" typeface="Iskoola Pota"/>
+        <a:font script="Mong" typeface="Mongolian Baiti"/>
+        <a:font script="Viet" typeface="Times New Roman"/>
+        <a:font script="Uigh" typeface="Microsoft Uighur"/>
+        <a:font script="Geor" typeface="Sylfaen"/>
+        <a:font script="Armn" typeface="Arial"/>
+        <a:font script="Bugi" typeface="Leelawadee UI"/>
+        <a:font script="Bopo" typeface="Microsoft JhengHei"/>
+        <a:font script="Java" typeface="Javanese Text"/>
+        <a:font script="Lisu" typeface="Segoe UI"/>
+        <a:font script="Mymr" typeface="Myanmar Text"/>
+        <a:font script="Nkoo" typeface="Ebrima"/>
+        <a:font script="Olck" typeface="Nirmala UI"/>
+        <a:font script="Osma" typeface="Ebrima"/>
+        <a:font script="Phag" typeface="Phagspa"/>
+        <a:font script="Syrn" typeface="Estrangelo Edessa"/>
+        <a:font script="Syrj" typeface="Estrangelo Edessa"/>
+        <a:font script="Syre" typeface="Estrangelo Edessa"/>
+        <a:font script="Sora" typeface="Nirmala UI"/>
+        <a:font script="Tale" typeface="Microsoft Tai Le"/>
+        <a:font script="Talu" typeface="Microsoft New Tai Lue"/>
+        <a:font script="Tfng" typeface="Ebrima"/>
+      </a:majorFont>
+      <a:minorFont>
+        <a:latin typeface="Calibri" panose="020F0502020204030204"/>
+        <a:ea typeface=""/>
+        <a:cs typeface=""/>
+        <a:font script="Jpan" typeface="游ゴシック"/>
+        <a:font script="Hang" typeface="맑은 고딕"/>
+        <a:font script="Hans" typeface="等线"/>
+        <a:font script="Hant" typeface="新細明體"/>
+        <a:font script="Arab" typeface="Arial"/>
+        <a:font script="Hebr" typeface="Arial"/>
+        <a:font script="Thai" typeface="Cordia New"/>
+        <a:font script="Ethi" typeface="Nyala"/>
+        <a:font script="Beng" typeface="Vrinda"/>
+        <a:font script="Gujr" typeface="Shruti"/>
+        <a:font script="Khmr" typeface="DaunPenh"/>
+        <a:font script="Knda" typeface="Tunga"/>
+        <a:font script="Guru" typeface="Raavi"/>
+        <a:font script="Cans" typeface="Euphemia"/>
+        <a:font script="Cher" typeface="Plantagenet Cherokee"/>
+        <a:font script="Yiii" typeface="Microsoft Yi Baiti"/>
+        <a:font script="Tibt" typeface="Microsoft Himalaya"/>
+        <a:font script="Thaa" typeface="MV Boli"/>
+        <a:font script="Deva" typeface="Mangal"/>
+        <a:font script="Telu" typeface="Gautami"/>
+        <a:font script="Taml" typeface="Latha"/>
+        <a:font script="Syrc" typeface="Estrangelo Edessa"/>
+        <a:font script="Orya" typeface="Kalinga"/>
+        <a:font script="Mlym" typeface="Kartika"/>
+        <a:font script="Laoo" typeface="DokChampa"/>
+        <a:font script="Sinh" typeface="Iskoola Pota"/>
+        <a:font script="Mong" typeface="Mongolian Baiti"/>
+        <a:font script="Viet" typeface="Arial"/>
+        <a:font script="Uigh" typeface="Microsoft Uighur"/>
+        <a:font script="Geor" typeface="Sylfaen"/>
+        <a:font script="Armn" typeface="Arial"/>
+        <a:font script="Bugi" typeface="Leelawadee UI"/>
+        <a:font script="Bopo" typeface="Microsoft JhengHei"/>
+        <a:font script="Java" typeface="Javanese Text"/>
+        <a:font script="Lisu" typeface="Segoe UI"/>
+        <a:font script="Mymr" typeface="Myanmar Text"/>
+        <a:font script="Nkoo" typeface="Ebrima"/>
+        <a:font script="Olck" typeface="Nirmala UI"/>
+        <a:font script="Osma" typeface="Ebrima"/>
+        <a:font script="Phag" typeface="Phagspa"/>
+        <a:font script="Syrn" typeface="Estrangelo Edessa"/>
+        <a:font script="Syrj" typeface="Estrangelo Edessa"/>
+        <a:font script="Syre" typeface="Estrangelo Edessa"/>
+        <a:font script="Sora" typeface="Nirmala UI"/>
+        <a:font script="Tale" typeface="Microsoft Tai Le"/>
+        <a:font script="Talu" typeface="Microsoft New Tai Lue"/>
+        <a:font script="Tfng" typeface="Ebrima"/>
+      </a:minorFont>
+    </a:fontScheme>
+    <a:fmtScheme name="Office">
+      <a:fillStyleLst>
+        <a:solidFill>
+          <a:schemeClr val="phClr"/>
+        </a:solidFill>
+        <a:gradFill rotWithShape="1">
+          <a:gsLst>
+            <a:gs pos="0">
+              <a:schemeClr val="phClr">
+                <a:lumMod val="110000"/>
+                <a:satMod val="105000"/>
+                <a:tint val="67000"/>
+              </a:schemeClr>
+            </a:gs>
+            <a:gs pos="50000">
+              <a:schemeClr val="phClr">
+                <a:lumMod val="105000"/>
+                <a:satMod val="103000"/>
+                <a:tint val="73000"/>
+              </a:schemeClr>
+            </a:gs>
+            <a:gs pos="100000">
+              <a:schemeClr val="phClr">
+                <a:lumMod val="105000"/>
+                <a:satMod val="109000"/>
+                <a:tint val="81000"/>
+              </a:schemeClr>
+            </a:gs>
+          </a:gsLst>
+          <a:lin ang="5400000" scaled="0"/>
+        </a:gradFill>
+        <a:gradFill rotWithShape="1">
+          <a:gsLst>
+            <a:gs pos="0">
+              <a:schemeClr val="phClr">
+                <a:satMod val="103000"/>
+                <a:lumMod val="102000"/>
+                <a:tint val="94000"/>
+              </a:schemeClr>
+            </a:gs>
+            <a:gs pos="50000">
+              <a:schemeClr val="phClr">
+                <a:satMod val="110000"/>
+                <a:lumMod val="100000"/>
+                <a:shade val="100000"/>
+              </a:schemeClr>
+            </a:gs>
+            <a:gs pos="100000">
+              <a:schemeClr val="phClr">
+                <a:lumMod val="99000"/>
+                <a:satMod val="120000"/>
+                <a:shade val="78000"/>
+              </a:schemeClr>
+            </a:gs>
+          </a:gsLst>
+          <a:lin ang="5400000" scaled="0"/>
+        </a:gradFill>
+      </a:fillStyleLst>
+      <a:lnStyleLst>
+        <a:ln w="6350" cap="flat" cmpd="sng" algn="ctr">
+          <a:solidFill>
+            <a:schemeClr val="phClr"/>
+          </a:solidFill>
+          <a:prstDash val="solid"/>
+          <a:miter lim="800000"/>
+        </a:ln>
+        <a:ln w="12700" cap="flat" cmpd="sng" algn="ctr">
+          <a:solidFill>
+            <a:schemeClr val="phClr"/>
+          </a:solidFill>
+          <a:prstDash val="solid"/>
+          <a:miter lim="800000"/>
+        </a:ln>
+        <a:ln w="19050" cap="flat" cmpd="sng" algn="ctr">
+          <a:solidFill>
+            <a:schemeClr val="phClr"/>
+          </a:solidFill>
+          <a:prstDash val="solid"/>
+          <a:miter lim="800000"/>
+        </a:ln>
+      </a:lnStyleLst>
+      <a:effectStyleLst>
+        <a:effectStyle>
+          <a:effectLst/>
+        </a:effectStyle>
+        <a:effectStyle>
+          <a:effectLst/>
+        </a:effectStyle>
+        <a:effectStyle>
+          <a:effectLst>
+            <a:outerShdw blurRad="57150" dist="19050" dir="5400000" algn="ctr" rotWithShape="0">
+              <a:srgbClr val="000000">
+                <a:alpha val="63000"/>
+              </a:srgbClr>
+            </a:outerShdw>
+          </a:effectLst>
+        </a:effectStyle>
+      </a:effectStyleLst>
+      <a:bgFillStyleLst>
+        <a:solidFill>
+          <a:schemeClr val="phClr"/>
+        </a:solidFill>
+        <a:solidFill>
+          <a:schemeClr val="phClr">
+            <a:tint val="95000"/>
+            <a:satMod val="170000"/>
+          </a:schemeClr>
+        </a:solidFill>
+        <a:gradFill rotWithShape="1">
+          <a:gsLst>
+            <a:gs pos="0">
+              <a:schemeClr val="phClr">
+                <a:tint val="93000"/>
+                <a:satMod val="150000"/>
+                <a:shade val="98000"/>
+                <a:lumMod val="102000"/>
+              </a:schemeClr>
+            </a:gs>
+            <a:gs pos="50000">
+              <a:schemeClr val="phClr">
+                <a:tint val="98000"/>
+                <a:satMod val="130000"/>
+                <a:shade val="90000"/>
+                <a:lumMod val="103000"/>
+              </a:schemeClr>
+            </a:gs>
+            <a:gs pos="100000">
+              <a:schemeClr val="phClr">
+                <a:shade val="63000"/>
+                <a:satMod val="120000"/>
+              </a:schemeClr>
+            </a:gs>
+          </a:gsLst>
+          <a:lin ang="5400000" scaled="0"/>
+        </a:gradFill>
+      </a:bgFillStyleLst>
+    </a:fmtScheme>
+  </a:themeElements>
+  <a:objectDefaults/>
+  <a:extraClrSchemeLst/>
+  <a:extLst>
+    <a:ext uri="{05A4C25C-085E-4340-85A3-A5531E510DB2}">
+      <thm15:themeFamily xmlns:thm15="http://schemas.microsoft.com/office/thememl/2012/main" name="Office Theme" id="{62F939B6-93AF-4DB8-9C6B-D6C7DFDC589F}" vid="{4A3C46E8-61CC-4603-A589-7422A47A8E4A}"/>
+    </a:ext>
+  </a:extLst>
+</a:theme>
 </file>
</xml_diff>